<commit_message>
507 part1 after feedback
</commit_message>
<xml_diff>
--- a/2026-T4/ICTSAD507-Design_ImplQA_processes/task2/2-Presentation.pptx
+++ b/2026-T4/ICTSAD507-Design_ImplQA_processes/task2/2-Presentation.pptx
@@ -121,6 +121,11 @@
       </a:defRPr>
     </a:lvl9pPr>
   </p:defaultTextStyle>
+  <p:extLst>
+    <p:ext uri="{EFAFB233-063F-42B5-8137-9DF3F51BA10A}">
+      <p15:sldGuideLst xmlns:p15="http://schemas.microsoft.com/office/powerpoint/2012/main"/>
+    </p:ext>
+  </p:extLst>
 </p:presentation>
 </file>
 
@@ -206,7 +211,7 @@
           <a:p>
             <a:fld id="{A2A45CFF-950A-4041-8C74-DADB5D97DAF6}" type="datetimeFigureOut">
               <a:rPr lang="en-AU" smtClean="0"/>
-              <a:t>15/10/2026</a:t>
+              <a:t>17/10/2026</a:t>
             </a:fld>
             <a:endParaRPr lang="en-AU"/>
           </a:p>
@@ -2077,7 +2082,7 @@
           <a:p>
             <a:fld id="{B3F85AFC-B25C-9A42-9D1F-183747EA9F71}" type="datetimeFigureOut">
               <a:rPr lang="en-AU" smtClean="0"/>
-              <a:t>15/10/2026</a:t>
+              <a:t>17/10/2026</a:t>
             </a:fld>
             <a:endParaRPr lang="en-AU"/>
           </a:p>
@@ -2397,7 +2402,7 @@
           <a:p>
             <a:fld id="{B3F85AFC-B25C-9A42-9D1F-183747EA9F71}" type="datetimeFigureOut">
               <a:rPr lang="en-AU" smtClean="0"/>
-              <a:t>15/10/2026</a:t>
+              <a:t>17/10/2026</a:t>
             </a:fld>
             <a:endParaRPr lang="en-AU"/>
           </a:p>
@@ -2645,7 +2650,7 @@
           <a:p>
             <a:fld id="{B3F85AFC-B25C-9A42-9D1F-183747EA9F71}" type="datetimeFigureOut">
               <a:rPr lang="en-AU" smtClean="0"/>
-              <a:t>15/10/2026</a:t>
+              <a:t>17/10/2026</a:t>
             </a:fld>
             <a:endParaRPr lang="en-AU"/>
           </a:p>
@@ -2984,7 +2989,7 @@
           <a:p>
             <a:fld id="{B3F85AFC-B25C-9A42-9D1F-183747EA9F71}" type="datetimeFigureOut">
               <a:rPr lang="en-AU" smtClean="0"/>
-              <a:t>15/10/2026</a:t>
+              <a:t>17/10/2026</a:t>
             </a:fld>
             <a:endParaRPr lang="en-AU"/>
           </a:p>
@@ -3331,7 +3336,7 @@
           <a:p>
             <a:fld id="{B3F85AFC-B25C-9A42-9D1F-183747EA9F71}" type="datetimeFigureOut">
               <a:rPr lang="en-AU" smtClean="0"/>
-              <a:t>15/10/2026</a:t>
+              <a:t>17/10/2026</a:t>
             </a:fld>
             <a:endParaRPr lang="en-AU"/>
           </a:p>
@@ -3705,7 +3710,7 @@
           <a:p>
             <a:fld id="{B3F85AFC-B25C-9A42-9D1F-183747EA9F71}" type="datetimeFigureOut">
               <a:rPr lang="en-AU" smtClean="0"/>
-              <a:t>15/10/2026</a:t>
+              <a:t>17/10/2026</a:t>
             </a:fld>
             <a:endParaRPr lang="en-AU"/>
           </a:p>
@@ -4175,7 +4180,7 @@
           <a:p>
             <a:fld id="{B3F85AFC-B25C-9A42-9D1F-183747EA9F71}" type="datetimeFigureOut">
               <a:rPr lang="en-AU" smtClean="0"/>
-              <a:t>15/10/2026</a:t>
+              <a:t>17/10/2026</a:t>
             </a:fld>
             <a:endParaRPr lang="en-AU"/>
           </a:p>
@@ -4380,7 +4385,7 @@
           <a:p>
             <a:fld id="{B3F85AFC-B25C-9A42-9D1F-183747EA9F71}" type="datetimeFigureOut">
               <a:rPr lang="en-AU" smtClean="0"/>
-              <a:t>15/10/2026</a:t>
+              <a:t>17/10/2026</a:t>
             </a:fld>
             <a:endParaRPr lang="en-AU"/>
           </a:p>
@@ -4591,7 +4596,7 @@
           <a:p>
             <a:fld id="{B3F85AFC-B25C-9A42-9D1F-183747EA9F71}" type="datetimeFigureOut">
               <a:rPr lang="en-AU" smtClean="0"/>
-              <a:t>15/10/2026</a:t>
+              <a:t>17/10/2026</a:t>
             </a:fld>
             <a:endParaRPr lang="en-AU"/>
           </a:p>
@@ -4914,7 +4919,7 @@
           </a:prstGeom>
           <a:extLst>
             <a:ext uri="{C572A759-6A51-4108-AA02-DFA0A04FC94B}">
-              <ma14:wrappingTextBoxFlag xmlns:ma14="http://schemas.microsoft.com/office/mac/drawingml/2011/main" xmlns="" val="0"/>
+              <ma14:wrappingTextBoxFlag xmlns="" xmlns:ma14="http://schemas.microsoft.com/office/mac/drawingml/2011/main" val="0"/>
             </a:ext>
           </a:extLst>
         </p:spPr>
@@ -5092,7 +5097,7 @@
           <a:p>
             <a:fld id="{B3F85AFC-B25C-9A42-9D1F-183747EA9F71}" type="datetimeFigureOut">
               <a:rPr lang="en-AU" smtClean="0"/>
-              <a:t>15/10/2026</a:t>
+              <a:t>17/10/2026</a:t>
             </a:fld>
             <a:endParaRPr lang="en-AU"/>
           </a:p>
@@ -5231,7 +5236,7 @@
           </a:prstGeom>
           <a:extLst>
             <a:ext uri="{C572A759-6A51-4108-AA02-DFA0A04FC94B}">
-              <ma14:wrappingTextBoxFlag xmlns:ma14="http://schemas.microsoft.com/office/mac/drawingml/2011/main" xmlns="" val="0"/>
+              <ma14:wrappingTextBoxFlag xmlns="" xmlns:ma14="http://schemas.microsoft.com/office/mac/drawingml/2011/main" val="0"/>
             </a:ext>
           </a:extLst>
         </p:spPr>
@@ -5456,7 +5461,7 @@
           <a:p>
             <a:fld id="{B3F85AFC-B25C-9A42-9D1F-183747EA9F71}" type="datetimeFigureOut">
               <a:rPr lang="en-AU" smtClean="0"/>
-              <a:t>15/10/2026</a:t>
+              <a:t>17/10/2026</a:t>
             </a:fld>
             <a:endParaRPr lang="en-AU"/>
           </a:p>
@@ -5754,7 +5759,7 @@
           <a:p>
             <a:fld id="{B3F85AFC-B25C-9A42-9D1F-183747EA9F71}" type="datetimeFigureOut">
               <a:rPr lang="en-AU" smtClean="0"/>
-              <a:t>15/10/2026</a:t>
+              <a:t>17/10/2026</a:t>
             </a:fld>
             <a:endParaRPr lang="en-AU"/>
           </a:p>
@@ -6148,7 +6153,7 @@
           <a:p>
             <a:fld id="{B3F85AFC-B25C-9A42-9D1F-183747EA9F71}" type="datetimeFigureOut">
               <a:rPr lang="en-AU" smtClean="0"/>
-              <a:t>15/10/2026</a:t>
+              <a:t>17/10/2026</a:t>
             </a:fld>
             <a:endParaRPr lang="en-AU"/>
           </a:p>
@@ -6297,7 +6302,7 @@
           <a:p>
             <a:fld id="{B3F85AFC-B25C-9A42-9D1F-183747EA9F71}" type="datetimeFigureOut">
               <a:rPr lang="en-AU" smtClean="0"/>
-              <a:t>15/10/2026</a:t>
+              <a:t>17/10/2026</a:t>
             </a:fld>
             <a:endParaRPr lang="en-AU"/>
           </a:p>
@@ -6423,7 +6428,7 @@
           <a:p>
             <a:fld id="{B3F85AFC-B25C-9A42-9D1F-183747EA9F71}" type="datetimeFigureOut">
               <a:rPr lang="en-AU" smtClean="0"/>
-              <a:t>15/10/2026</a:t>
+              <a:t>17/10/2026</a:t>
             </a:fld>
             <a:endParaRPr lang="en-AU"/>
           </a:p>
@@ -6678,7 +6683,7 @@
           <a:p>
             <a:fld id="{B3F85AFC-B25C-9A42-9D1F-183747EA9F71}" type="datetimeFigureOut">
               <a:rPr lang="en-AU" smtClean="0"/>
-              <a:t>15/10/2026</a:t>
+              <a:t>17/10/2026</a:t>
             </a:fld>
             <a:endParaRPr lang="en-AU"/>
           </a:p>
@@ -6989,7 +6994,7 @@
           <a:p>
             <a:fld id="{B3F85AFC-B25C-9A42-9D1F-183747EA9F71}" type="datetimeFigureOut">
               <a:rPr lang="en-AU" smtClean="0"/>
-              <a:t>15/10/2026</a:t>
+              <a:t>17/10/2026</a:t>
             </a:fld>
             <a:endParaRPr lang="en-AU"/>
           </a:p>
@@ -7340,7 +7345,7 @@
           <a:p>
             <a:fld id="{B3F85AFC-B25C-9A42-9D1F-183747EA9F71}" type="datetimeFigureOut">
               <a:rPr lang="en-AU" smtClean="0"/>
-              <a:t>15/10/2026</a:t>
+              <a:t>17/10/2026</a:t>
             </a:fld>
             <a:endParaRPr lang="en-AU"/>
           </a:p>
@@ -8384,7 +8389,7 @@
           </a:prstGeom>
           <a:extLst>
             <a:ext uri="{C572A759-6A51-4108-AA02-DFA0A04FC94B}">
-              <ma14:wrappingTextBoxFlag xmlns:ma14="http://schemas.microsoft.com/office/mac/drawingml/2011/main" xmlns="" val="0"/>
+              <ma14:wrappingTextBoxFlag xmlns="" xmlns:ma14="http://schemas.microsoft.com/office/mac/drawingml/2011/main" val="0"/>
             </a:ext>
           </a:extLst>
         </p:spPr>
@@ -8576,7 +8581,7 @@
           </a:prstGeom>
           <a:extLst>
             <a:ext uri="{C572A759-6A51-4108-AA02-DFA0A04FC94B}">
-              <ma14:wrappingTextBoxFlag xmlns:ma14="http://schemas.microsoft.com/office/mac/drawingml/2011/main" xmlns="" val="0"/>
+              <ma14:wrappingTextBoxFlag xmlns="" xmlns:ma14="http://schemas.microsoft.com/office/mac/drawingml/2011/main" val="0"/>
             </a:ext>
           </a:extLst>
         </p:spPr>
@@ -9295,7 +9300,7 @@
           </a:prstGeom>
           <a:extLst>
             <a:ext uri="{C572A759-6A51-4108-AA02-DFA0A04FC94B}">
-              <ma14:wrappingTextBoxFlag xmlns:ma14="http://schemas.microsoft.com/office/mac/drawingml/2011/main" xmlns="" val="0"/>
+              <ma14:wrappingTextBoxFlag xmlns="" xmlns:ma14="http://schemas.microsoft.com/office/mac/drawingml/2011/main" val="0"/>
             </a:ext>
           </a:extLst>
         </p:spPr>
@@ -10295,6 +10300,10 @@
           </p:nvPr>
         </p:nvSpPr>
         <p:spPr>
+          <a:xfrm>
+            <a:off x="548640" y="1463040"/>
+            <a:ext cx="11064240" cy="4108027"/>
+          </a:xfrm>
           <a:prstGeom prst="rect">
             <a:avLst/>
           </a:prstGeom>
@@ -10302,230 +10311,56 @@
           <a:ln/>
         </p:spPr>
         <p:txBody>
-          <a:bodyPr wrap="square" rtlCol="0" anchor="t"/>
+          <a:bodyPr wrap="square" rtlCol="0" anchor="t">
+            <a:normAutofit/>
+          </a:bodyPr>
           <a:lstStyle/>
           <a:p>
-            <a:pPr marL="342900" indent="-342900" algn="l">
-              <a:spcAft>
-                <a:spcPts val="1000"/>
-              </a:spcAft>
-              <a:buSzPct val="100000"/>
+            <a:pPr marL="342900" indent="-342900">
               <a:buFont typeface="+mj-lt"/>
               <a:buAutoNum type="arabicPeriod"/>
             </a:pPr>
             <a:r>
-              <a:rPr lang="en-US" sz="1800" dirty="0">
-                <a:solidFill>
-                  <a:schemeClr val="tx1"/>
-                </a:solidFill>
-              </a:rPr>
-              <a:t>What </a:t>
-            </a:r>
-            <a:r>
-              <a:rPr lang="en-US" sz="1800" b="1" dirty="0">
-                <a:solidFill>
-                  <a:schemeClr val="tx1"/>
-                </a:solidFill>
-              </a:rPr>
-              <a:t>experience</a:t>
-            </a:r>
-            <a:r>
-              <a:rPr lang="en-US" sz="1800" dirty="0">
-                <a:solidFill>
-                  <a:schemeClr val="tx1"/>
-                </a:solidFill>
-              </a:rPr>
-              <a:t> do you have in testing websites, such as online enrolment forms, responsive design on mobile devices and links between systems, and where would you need training?</a:t>
-            </a:r>
-            <a:endParaRPr lang="en-US" sz="1800" dirty="0"/>
-          </a:p>
-          <a:p>
-            <a:pPr marL="342900" indent="-342900" algn="l">
-              <a:spcAft>
-                <a:spcPts val="1000"/>
-              </a:spcAft>
-              <a:buSzPct val="100000"/>
+              <a:rPr lang="en-AU" sz="2400" dirty="0"/>
+              <a:t>Which quality-related roles and key tasks can you competently perform on the project?</a:t>
+            </a:r>
+          </a:p>
+          <a:p>
+            <a:pPr marL="342900" indent="-342900">
               <a:buFont typeface="+mj-lt"/>
               <a:buAutoNum type="arabicPeriod"/>
             </a:pPr>
             <a:r>
-              <a:rPr lang="en-US" sz="1800" dirty="0">
-                <a:solidFill>
-                  <a:schemeClr val="tx1"/>
-                </a:solidFill>
-              </a:rPr>
-              <a:t>How </a:t>
-            </a:r>
-            <a:r>
-              <a:rPr lang="en-US" sz="1800" b="1" dirty="0">
-                <a:solidFill>
-                  <a:schemeClr val="tx1"/>
-                </a:solidFill>
-              </a:rPr>
-              <a:t>confident</a:t>
-            </a:r>
-            <a:r>
-              <a:rPr lang="en-US" sz="1800" dirty="0">
-                <a:solidFill>
-                  <a:schemeClr val="tx1"/>
-                </a:solidFill>
-              </a:rPr>
-              <a:t> are you in recording issues and test </a:t>
-            </a:r>
-            <a:r>
-              <a:rPr lang="en-US" sz="1800" b="1" dirty="0">
-                <a:solidFill>
-                  <a:schemeClr val="tx1"/>
-                </a:solidFill>
-              </a:rPr>
-              <a:t>results</a:t>
-            </a:r>
-            <a:r>
-              <a:rPr lang="en-US" sz="1800" dirty="0">
-                <a:solidFill>
-                  <a:schemeClr val="tx1"/>
-                </a:solidFill>
-              </a:rPr>
-              <a:t> in the project issues register so another team member can follow them up?</a:t>
-            </a:r>
-            <a:endParaRPr lang="en-US" sz="1800" dirty="0"/>
-          </a:p>
-          <a:p>
-            <a:pPr marL="342900" indent="-342900" algn="l">
-              <a:spcAft>
-                <a:spcPts val="1000"/>
-              </a:spcAft>
-              <a:buSzPct val="100000"/>
+              <a:rPr lang="en-AU" sz="2400" dirty="0"/>
+              <a:t>Are you able to cover each of the following areas of interest?</a:t>
+            </a:r>
+          </a:p>
+          <a:p>
+            <a:pPr marL="342900" indent="-342900">
               <a:buFont typeface="+mj-lt"/>
               <a:buAutoNum type="arabicPeriod"/>
             </a:pPr>
             <a:r>
-              <a:rPr lang="en-US" sz="1800" dirty="0">
-                <a:solidFill>
-                  <a:schemeClr val="tx1"/>
-                </a:solidFill>
-              </a:rPr>
-              <a:t>What </a:t>
-            </a:r>
-            <a:r>
-              <a:rPr lang="en-US" sz="1800" b="1" dirty="0">
-                <a:solidFill>
-                  <a:schemeClr val="tx1"/>
-                </a:solidFill>
-              </a:rPr>
-              <a:t>experience</a:t>
-            </a:r>
-            <a:r>
-              <a:rPr lang="en-US" sz="1800" dirty="0">
-                <a:solidFill>
-                  <a:schemeClr val="tx1"/>
-                </a:solidFill>
-              </a:rPr>
-              <a:t> do you have in </a:t>
-            </a:r>
-            <a:r>
-              <a:rPr lang="en-US" sz="1800" b="1" dirty="0">
-                <a:solidFill>
-                  <a:schemeClr val="tx1"/>
-                </a:solidFill>
-              </a:rPr>
-              <a:t>communicating</a:t>
-            </a:r>
-            <a:r>
-              <a:rPr lang="en-US" sz="1800" dirty="0">
-                <a:solidFill>
-                  <a:schemeClr val="tx1"/>
-                </a:solidFill>
-              </a:rPr>
-              <a:t> with and following up an external web developer when timelines are at risk?</a:t>
-            </a:r>
-            <a:endParaRPr lang="en-US" sz="1800" dirty="0"/>
-          </a:p>
-          <a:p>
-            <a:pPr marL="342900" indent="-342900" algn="l">
-              <a:spcAft>
-                <a:spcPts val="1000"/>
-              </a:spcAft>
-              <a:buSzPct val="100000"/>
+              <a:rPr lang="en-AU" sz="2400" dirty="0"/>
+              <a:t>Are there any skills or knowledge gaps that could affect? training, support or specialist expertise required? </a:t>
+            </a:r>
+          </a:p>
+          <a:p>
+            <a:pPr marL="342900" indent="-342900">
               <a:buFont typeface="+mj-lt"/>
               <a:buAutoNum type="arabicPeriod"/>
             </a:pPr>
             <a:r>
-              <a:rPr lang="en-US" sz="1800" dirty="0">
-                <a:solidFill>
-                  <a:schemeClr val="tx1"/>
-                </a:solidFill>
-              </a:rPr>
-              <a:t>Would you be able to </a:t>
-            </a:r>
-            <a:r>
-              <a:rPr lang="en-US" sz="1800" b="1" dirty="0">
-                <a:solidFill>
-                  <a:schemeClr val="tx1"/>
-                </a:solidFill>
-              </a:rPr>
-              <a:t>maintain</a:t>
-            </a:r>
-            <a:r>
-              <a:rPr lang="en-US" sz="1800" dirty="0">
-                <a:solidFill>
-                  <a:schemeClr val="tx1"/>
-                </a:solidFill>
-              </a:rPr>
-              <a:t> and </a:t>
-            </a:r>
-            <a:r>
-              <a:rPr lang="en-US" sz="1800" b="1" dirty="0">
-                <a:solidFill>
-                  <a:schemeClr val="tx1"/>
-                </a:solidFill>
-              </a:rPr>
-              <a:t>update</a:t>
-            </a:r>
-            <a:r>
-              <a:rPr lang="en-US" sz="1800" dirty="0">
-                <a:solidFill>
-                  <a:schemeClr val="tx1"/>
-                </a:solidFill>
-              </a:rPr>
-              <a:t> the website after go-live, or would you need training?</a:t>
-            </a:r>
-            <a:endParaRPr lang="en-US" sz="1800" dirty="0"/>
-          </a:p>
-          <a:p>
-            <a:pPr marL="342900" indent="-342900" algn="l">
-              <a:spcAft>
-                <a:spcPts val="1000"/>
-              </a:spcAft>
-              <a:buSzPct val="100000"/>
+              <a:rPr lang="en-AU" sz="2400"/>
+              <a:t>Do you identify with the standards required to ensure that quality objectives are met?</a:t>
+            </a:r>
+          </a:p>
+          <a:p>
+            <a:pPr marL="342900" indent="-342900">
               <a:buFont typeface="+mj-lt"/>
               <a:buAutoNum type="arabicPeriod"/>
             </a:pPr>
-            <a:r>
-              <a:rPr lang="en-US" sz="1800" dirty="0">
-                <a:solidFill>
-                  <a:schemeClr val="tx1"/>
-                </a:solidFill>
-              </a:rPr>
-              <a:t>How familiar are you with </a:t>
-            </a:r>
-            <a:r>
-              <a:rPr lang="en-US" sz="1800" b="1" dirty="0">
-                <a:solidFill>
-                  <a:schemeClr val="tx1"/>
-                </a:solidFill>
-              </a:rPr>
-              <a:t>privacy requirements </a:t>
-            </a:r>
-            <a:r>
-              <a:rPr lang="en-US" sz="1800" dirty="0">
-                <a:solidFill>
-                  <a:schemeClr val="tx1"/>
-                </a:solidFill>
-              </a:rPr>
-              <a:t>when handling student information in the website and accounting system?</a:t>
-            </a:r>
-            <a:endParaRPr lang="en-US" sz="1800" dirty="0"/>
+            <a:endParaRPr lang="en-AU" sz="2400" dirty="0"/>
           </a:p>
         </p:txBody>
       </p:sp>
@@ -10549,7 +10384,7 @@
           </a:prstGeom>
           <a:extLst>
             <a:ext uri="{C572A759-6A51-4108-AA02-DFA0A04FC94B}">
-              <ma14:wrappingTextBoxFlag xmlns:ma14="http://schemas.microsoft.com/office/mac/drawingml/2011/main" xmlns="" val="0"/>
+              <ma14:wrappingTextBoxFlag xmlns="" xmlns:ma14="http://schemas.microsoft.com/office/mac/drawingml/2011/main" val="0"/>
             </a:ext>
           </a:extLst>
         </p:spPr>
@@ -10574,38 +10409,6 @@
           </a:p>
         </p:txBody>
       </p:sp>
-      <p:pic>
-        <p:nvPicPr>
-          <p:cNvPr id="4" name="Picture 3" descr="Lupa logo Vectors - Download Free High-Quality Vectors | Magnific (formerly  Freepik)">
-            <a:extLst>
-              <a:ext uri="{FF2B5EF4-FFF2-40B4-BE49-F238E27FC236}">
-                <a16:creationId xmlns:a16="http://schemas.microsoft.com/office/drawing/2014/main" id="{CEFA940F-C03D-6585-4CF4-3C6393010978}"/>
-              </a:ext>
-            </a:extLst>
-          </p:cNvPr>
-          <p:cNvPicPr>
-            <a:picLocks noChangeAspect="1"/>
-          </p:cNvPicPr>
-          <p:nvPr/>
-        </p:nvPicPr>
-        <p:blipFill>
-          <a:blip r:embed="rId3">
-            <a:alphaModFix amt="21000"/>
-          </a:blip>
-          <a:stretch>
-            <a:fillRect/>
-          </a:stretch>
-        </p:blipFill>
-        <p:spPr>
-          <a:xfrm>
-            <a:off x="3263900" y="1079500"/>
-            <a:ext cx="5187950" cy="5187950"/>
-          </a:xfrm>
-          <a:prstGeom prst="rect">
-            <a:avLst/>
-          </a:prstGeom>
-        </p:spPr>
-      </p:pic>
     </p:spTree>
   </p:cSld>
   <p:clrMapOvr>
@@ -10811,7 +10614,7 @@
           </a:prstGeom>
           <a:extLst>
             <a:ext uri="{C572A759-6A51-4108-AA02-DFA0A04FC94B}">
-              <ma14:wrappingTextBoxFlag xmlns:ma14="http://schemas.microsoft.com/office/mac/drawingml/2011/main" xmlns="" val="0"/>
+              <ma14:wrappingTextBoxFlag xmlns="" xmlns:ma14="http://schemas.microsoft.com/office/mac/drawingml/2011/main" val="0"/>
             </a:ext>
           </a:extLst>
         </p:spPr>
@@ -11174,7 +10977,7 @@
           </a:prstGeom>
           <a:extLst>
             <a:ext uri="{C572A759-6A51-4108-AA02-DFA0A04FC94B}">
-              <ma14:wrappingTextBoxFlag xmlns:ma14="http://schemas.microsoft.com/office/mac/drawingml/2011/main" xmlns="" val="0"/>
+              <ma14:wrappingTextBoxFlag xmlns="" xmlns:ma14="http://schemas.microsoft.com/office/mac/drawingml/2011/main" val="0"/>
             </a:ext>
           </a:extLst>
         </p:spPr>
@@ -11342,7 +11145,7 @@
           </a:prstGeom>
           <a:extLst>
             <a:ext uri="{C572A759-6A51-4108-AA02-DFA0A04FC94B}">
-              <ma14:wrappingTextBoxFlag xmlns:ma14="http://schemas.microsoft.com/office/mac/drawingml/2011/main" xmlns="" val="0"/>
+              <ma14:wrappingTextBoxFlag xmlns="" xmlns:ma14="http://schemas.microsoft.com/office/mac/drawingml/2011/main" val="0"/>
             </a:ext>
           </a:extLst>
         </p:spPr>
@@ -12410,7 +12213,7 @@
           </a:prstGeom>
           <a:extLst>
             <a:ext uri="{C572A759-6A51-4108-AA02-DFA0A04FC94B}">
-              <ma14:wrappingTextBoxFlag xmlns:ma14="http://schemas.microsoft.com/office/mac/drawingml/2011/main" xmlns="" val="0"/>
+              <ma14:wrappingTextBoxFlag xmlns="" xmlns:ma14="http://schemas.microsoft.com/office/mac/drawingml/2011/main" val="0"/>
             </a:ext>
           </a:extLst>
         </p:spPr>
@@ -12642,7 +12445,7 @@
           </a:prstGeom>
           <a:extLst>
             <a:ext uri="{C572A759-6A51-4108-AA02-DFA0A04FC94B}">
-              <ma14:wrappingTextBoxFlag xmlns="" xmlns:ma14="http://schemas.microsoft.com/office/mac/drawingml/2011/main" val="0"/>
+              <ma14:wrappingTextBoxFlag xmlns:ma14="http://schemas.microsoft.com/office/mac/drawingml/2011/main" xmlns="" val="0"/>
             </a:ext>
           </a:extLst>
         </p:spPr>
@@ -12880,7 +12683,7 @@
           </a:prstGeom>
           <a:extLst>
             <a:ext uri="{C572A759-6A51-4108-AA02-DFA0A04FC94B}">
-              <ma14:wrappingTextBoxFlag xmlns:ma14="http://schemas.microsoft.com/office/mac/drawingml/2011/main" xmlns="" val="0"/>
+              <ma14:wrappingTextBoxFlag xmlns="" xmlns:ma14="http://schemas.microsoft.com/office/mac/drawingml/2011/main" val="0"/>
             </a:ext>
           </a:extLst>
         </p:spPr>
@@ -13119,7 +12922,7 @@
           </a:prstGeom>
           <a:extLst>
             <a:ext uri="{C572A759-6A51-4108-AA02-DFA0A04FC94B}">
-              <ma14:wrappingTextBoxFlag xmlns="" xmlns:ma14="http://schemas.microsoft.com/office/mac/drawingml/2011/main" val="0"/>
+              <ma14:wrappingTextBoxFlag xmlns:ma14="http://schemas.microsoft.com/office/mac/drawingml/2011/main" xmlns="" val="0"/>
             </a:ext>
           </a:extLst>
         </p:spPr>
@@ -13494,7 +13297,7 @@
           </a:prstGeom>
           <a:extLst>
             <a:ext uri="{C572A759-6A51-4108-AA02-DFA0A04FC94B}">
-              <ma14:wrappingTextBoxFlag xmlns:ma14="http://schemas.microsoft.com/office/mac/drawingml/2011/main" xmlns="" val="0"/>
+              <ma14:wrappingTextBoxFlag xmlns="" xmlns:ma14="http://schemas.microsoft.com/office/mac/drawingml/2011/main" val="0"/>
             </a:ext>
           </a:extLst>
         </p:spPr>
@@ -13842,7 +13645,7 @@
           </a:prstGeom>
           <a:extLst>
             <a:ext uri="{C572A759-6A51-4108-AA02-DFA0A04FC94B}">
-              <ma14:wrappingTextBoxFlag xmlns:ma14="http://schemas.microsoft.com/office/mac/drawingml/2011/main" xmlns="" val="0"/>
+              <ma14:wrappingTextBoxFlag xmlns="" xmlns:ma14="http://schemas.microsoft.com/office/mac/drawingml/2011/main" val="0"/>
             </a:ext>
           </a:extLst>
         </p:spPr>

</xml_diff>